<commit_message>
Add converted presentation files
</commit_message>
<xml_diff>
--- a/output/非エンジニアのためのGitHub基本操作_pushとpull.pptx
+++ b/output/非エンジニアのためのGitHub基本操作_pushとpull.pptx
@@ -18,8 +18,8 @@
   <p:notesMasterIdLst>
     <p:notesMasterId r:id="rId11"/>
   </p:notesMasterIdLst>
-  <p:sldSz cx="12192000" cy="6858000"/>
-  <p:notesSz cx="6858000" cy="12192000"/>
+  <p:sldSz cx="9144000" cy="6858000"/>
+  <p:notesSz cx="6858000" cy="9144000"/>
   <p:defaultTextStyle>
     <a:lvl1pPr marL="0" algn="l" defTabSz="914400" rtl="0" eaLnBrk="1" latinLnBrk="0" hangingPunct="1">
       <a:defRPr sz="1800" kern="1200">

</xml_diff>